<commit_message>
add just commands, add ability to delete current record, other cleanup
</commit_message>
<xml_diff>
--- a/docs/presentation.pptx
+++ b/docs/presentation.pptx
@@ -12,6 +12,12 @@
     <p:sldId id="260" r:id="slide5"/>
     <p:sldId id="261" r:id="slide6"/>
     <p:sldId id="262" r:id="slide7"/>
+    <p:sldId id="263" r:id="slide8"/>
+    <p:sldId id="264" r:id="slide9"/>
+    <p:sldId id="265" r:id="slide10"/>
+    <p:sldId id="266" r:id="slide11"/>
+    <p:sldId id="267" r:id="slide12"/>
+    <p:sldId id="268" r:id="slide13"/>
   </p:sldIdLst>
   <p:sldSz cx="9144000" cy="5143500" type="screen4x3"/>
   <p:notesSz cx="6858000" cy="9144000"/>
@@ -3133,8 +3139,8 @@
         </p:blipFill>
         <p:spPr>
           <a:xfrm>
-            <a:off x="0" y="274577"/>
-            <a:ext cx="9144000" cy="4594346"/>
+            <a:off x="1017784" y="0"/>
+            <a:ext cx="7108432" cy="5143500"/>
           </a:xfrm>
           <a:prstGeom prst="rect">
             <a:avLst/>
@@ -3144,6 +3150,362 @@
       <p:sp>
         <p:nvSpPr>
           <p:cNvPr id="95" name="root"/>
+          <p:cNvSpPr txBox="1"/>
+          <p:nvPr/>
+        </p:nvSpPr>
+        <p:spPr>
+          <a:xfrm>
+            <a:off x="4001" y="6239"/>
+            <a:ext cx="9135998" cy="0"/>
+          </a:xfrm>
+          <a:prstGeom prst="rect">
+            <a:avLst/>
+          </a:prstGeom>
+          <a:ln w="12700">
+            <a:miter lim="400000"/>
+          </a:ln>
+          <a:extLst>
+            <a:ext uri="{C572A759-6A51-4108-AA02-DFA0A04FC94B}">
+              <ma14:wrappingTextBoxFlag xmlns:ma14="http://schemas.microsoft.com/office/mac/drawingml/2011/main" xmlns="" val="1"/>
+            </a:ext>
+          </a:extLst>
+        </p:spPr>
+        <p:txBody>
+          <a:bodyPr lIns="45719" rIns="45719">
+            <a:spAutoFit/>
+          </a:bodyPr>
+          <a:lstStyle>
+            <a:lvl1pPr>
+              <a:defRPr sz="2400"/>
+            </a:lvl1pPr>
+          </a:lstStyle>
+          <a:p>
+            <a:r>
+              <a:rPr b="1"/>
+              <a:t/>
+            </a:r>
+          </a:p>
+        </p:txBody>
+      </p:sp>
+    </p:spTree>
+  </p:cSld>
+  <p:clrMapOvr>
+    <a:masterClrMapping/>
+  </p:clrMapOvr>
+</p:sld>
+</file>
+
+<file path=ppt/slides/slide10.xml><?xml version="1.0" encoding="utf-8"?>
+<p:sld xmlns:a="http://schemas.openxmlformats.org/drawingml/2006/main" xmlns:p="http://schemas.openxmlformats.org/presentationml/2006/main" xmlns:r="http://schemas.openxmlformats.org/officeDocument/2006/relationships">
+  <p:cSld>
+    <p:spTree>
+      <p:nvGrpSpPr>
+        <p:cNvPr id="1" name=""/>
+        <p:cNvGrpSpPr/>
+        <p:nvPr/>
+      </p:nvGrpSpPr>
+      <p:grpSpPr>
+        <a:xfrm>
+          <a:off x="0" y="0"/>
+          <a:ext cx="0" cy="0"/>
+          <a:chOff x="0" y="0"/>
+          <a:chExt cx="0" cy="0"/>
+        </a:xfrm>
+      </p:grpSpPr>
+      <p:pic>
+        <p:nvPicPr>
+          <p:cNvPr id="2" name="root.layers.9" descr="root.layers.9"/>
+          <p:cNvPicPr>
+            <a:picLocks noChangeAspect="1"/>
+          </p:cNvPicPr>
+          <p:nvPr/>
+        </p:nvPicPr>
+        <p:blipFill>
+          <a:blip r:embed="slide10Image"/>
+          <a:stretch>
+            <a:fillRect/>
+          </a:stretch>
+        </p:blipFill>
+        <p:spPr>
+          <a:xfrm>
+            <a:off x="0" y="769024"/>
+            <a:ext cx="9144000" cy="3605451"/>
+          </a:xfrm>
+          <a:prstGeom prst="rect">
+            <a:avLst/>
+          </a:prstGeom>
+        </p:spPr>
+      </p:pic>
+      <p:sp>
+        <p:nvSpPr>
+          <p:cNvPr id="95" name="root.layers.9"/>
+          <p:cNvSpPr txBox="1"/>
+          <p:nvPr/>
+        </p:nvSpPr>
+        <p:spPr>
+          <a:xfrm>
+            <a:off x="4001" y="6239"/>
+            <a:ext cx="9135998" cy="0"/>
+          </a:xfrm>
+          <a:prstGeom prst="rect">
+            <a:avLst/>
+          </a:prstGeom>
+          <a:ln w="12700">
+            <a:miter lim="400000"/>
+          </a:ln>
+          <a:extLst>
+            <a:ext uri="{C572A759-6A51-4108-AA02-DFA0A04FC94B}">
+              <ma14:wrappingTextBoxFlag xmlns:ma14="http://schemas.microsoft.com/office/mac/drawingml/2011/main" xmlns="" val="1"/>
+            </a:ext>
+          </a:extLst>
+        </p:spPr>
+        <p:txBody>
+          <a:bodyPr lIns="45719" rIns="45719">
+            <a:spAutoFit/>
+          </a:bodyPr>
+          <a:lstStyle>
+            <a:lvl1pPr>
+              <a:defRPr sz="2400"/>
+            </a:lvl1pPr>
+          </a:lstStyle>
+          <a:p>
+            <a:r>
+              <a:rPr b="1"/>
+              <a:t/>
+            </a:r>
+          </a:p>
+        </p:txBody>
+      </p:sp>
+    </p:spTree>
+  </p:cSld>
+  <p:clrMapOvr>
+    <a:masterClrMapping/>
+  </p:clrMapOvr>
+</p:sld>
+</file>
+
+<file path=ppt/slides/slide11.xml><?xml version="1.0" encoding="utf-8"?>
+<p:sld xmlns:a="http://schemas.openxmlformats.org/drawingml/2006/main" xmlns:p="http://schemas.openxmlformats.org/presentationml/2006/main" xmlns:r="http://schemas.openxmlformats.org/officeDocument/2006/relationships">
+  <p:cSld>
+    <p:spTree>
+      <p:nvGrpSpPr>
+        <p:cNvPr id="1" name=""/>
+        <p:cNvGrpSpPr/>
+        <p:nvPr/>
+      </p:nvGrpSpPr>
+      <p:grpSpPr>
+        <a:xfrm>
+          <a:off x="0" y="0"/>
+          <a:ext cx="0" cy="0"/>
+          <a:chOff x="0" y="0"/>
+          <a:chExt cx="0" cy="0"/>
+        </a:xfrm>
+      </p:grpSpPr>
+      <p:pic>
+        <p:nvPicPr>
+          <p:cNvPr id="2" name="root.layers.10" descr="root.layers.10"/>
+          <p:cNvPicPr>
+            <a:picLocks noChangeAspect="1"/>
+          </p:cNvPicPr>
+          <p:nvPr/>
+        </p:nvPicPr>
+        <p:blipFill>
+          <a:blip r:embed="slide11Image"/>
+          <a:stretch>
+            <a:fillRect/>
+          </a:stretch>
+        </p:blipFill>
+        <p:spPr>
+          <a:xfrm>
+            <a:off x="0" y="300127"/>
+            <a:ext cx="9144000" cy="4543245"/>
+          </a:xfrm>
+          <a:prstGeom prst="rect">
+            <a:avLst/>
+          </a:prstGeom>
+        </p:spPr>
+      </p:pic>
+      <p:sp>
+        <p:nvSpPr>
+          <p:cNvPr id="95" name="root.layers.10"/>
+          <p:cNvSpPr txBox="1"/>
+          <p:nvPr/>
+        </p:nvSpPr>
+        <p:spPr>
+          <a:xfrm>
+            <a:off x="4001" y="6239"/>
+            <a:ext cx="9135998" cy="0"/>
+          </a:xfrm>
+          <a:prstGeom prst="rect">
+            <a:avLst/>
+          </a:prstGeom>
+          <a:ln w="12700">
+            <a:miter lim="400000"/>
+          </a:ln>
+          <a:extLst>
+            <a:ext uri="{C572A759-6A51-4108-AA02-DFA0A04FC94B}">
+              <ma14:wrappingTextBoxFlag xmlns:ma14="http://schemas.microsoft.com/office/mac/drawingml/2011/main" xmlns="" val="1"/>
+            </a:ext>
+          </a:extLst>
+        </p:spPr>
+        <p:txBody>
+          <a:bodyPr lIns="45719" rIns="45719">
+            <a:spAutoFit/>
+          </a:bodyPr>
+          <a:lstStyle>
+            <a:lvl1pPr>
+              <a:defRPr sz="2400"/>
+            </a:lvl1pPr>
+          </a:lstStyle>
+          <a:p>
+            <a:r>
+              <a:rPr b="1"/>
+              <a:t/>
+            </a:r>
+          </a:p>
+        </p:txBody>
+      </p:sp>
+    </p:spTree>
+  </p:cSld>
+  <p:clrMapOvr>
+    <a:masterClrMapping/>
+  </p:clrMapOvr>
+</p:sld>
+</file>
+
+<file path=ppt/slides/slide12.xml><?xml version="1.0" encoding="utf-8"?>
+<p:sld xmlns:a="http://schemas.openxmlformats.org/drawingml/2006/main" xmlns:p="http://schemas.openxmlformats.org/presentationml/2006/main" xmlns:r="http://schemas.openxmlformats.org/officeDocument/2006/relationships">
+  <p:cSld>
+    <p:spTree>
+      <p:nvGrpSpPr>
+        <p:cNvPr id="1" name=""/>
+        <p:cNvGrpSpPr/>
+        <p:nvPr/>
+      </p:nvGrpSpPr>
+      <p:grpSpPr>
+        <a:xfrm>
+          <a:off x="0" y="0"/>
+          <a:ext cx="0" cy="0"/>
+          <a:chOff x="0" y="0"/>
+          <a:chExt cx="0" cy="0"/>
+        </a:xfrm>
+      </p:grpSpPr>
+      <p:pic>
+        <p:nvPicPr>
+          <p:cNvPr id="2" name="root.layers.11" descr="root.layers.11"/>
+          <p:cNvPicPr>
+            <a:picLocks noChangeAspect="1"/>
+          </p:cNvPicPr>
+          <p:nvPr/>
+        </p:nvPicPr>
+        <p:blipFill>
+          <a:blip r:embed="slide12Image"/>
+          <a:stretch>
+            <a:fillRect/>
+          </a:stretch>
+        </p:blipFill>
+        <p:spPr>
+          <a:xfrm>
+            <a:off x="0" y="936414"/>
+            <a:ext cx="9144000" cy="3270671"/>
+          </a:xfrm>
+          <a:prstGeom prst="rect">
+            <a:avLst/>
+          </a:prstGeom>
+        </p:spPr>
+      </p:pic>
+      <p:sp>
+        <p:nvSpPr>
+          <p:cNvPr id="95" name="root.layers.11"/>
+          <p:cNvSpPr txBox="1"/>
+          <p:nvPr/>
+        </p:nvSpPr>
+        <p:spPr>
+          <a:xfrm>
+            <a:off x="4001" y="6239"/>
+            <a:ext cx="9135998" cy="0"/>
+          </a:xfrm>
+          <a:prstGeom prst="rect">
+            <a:avLst/>
+          </a:prstGeom>
+          <a:ln w="12700">
+            <a:miter lim="400000"/>
+          </a:ln>
+          <a:extLst>
+            <a:ext uri="{C572A759-6A51-4108-AA02-DFA0A04FC94B}">
+              <ma14:wrappingTextBoxFlag xmlns:ma14="http://schemas.microsoft.com/office/mac/drawingml/2011/main" xmlns="" val="1"/>
+            </a:ext>
+          </a:extLst>
+        </p:spPr>
+        <p:txBody>
+          <a:bodyPr lIns="45719" rIns="45719">
+            <a:spAutoFit/>
+          </a:bodyPr>
+          <a:lstStyle>
+            <a:lvl1pPr>
+              <a:defRPr sz="2400"/>
+            </a:lvl1pPr>
+          </a:lstStyle>
+          <a:p>
+            <a:r>
+              <a:rPr b="1"/>
+              <a:t/>
+            </a:r>
+          </a:p>
+        </p:txBody>
+      </p:sp>
+    </p:spTree>
+  </p:cSld>
+  <p:clrMapOvr>
+    <a:masterClrMapping/>
+  </p:clrMapOvr>
+</p:sld>
+</file>
+
+<file path=ppt/slides/slide13.xml><?xml version="1.0" encoding="utf-8"?>
+<p:sld xmlns:a="http://schemas.openxmlformats.org/drawingml/2006/main" xmlns:p="http://schemas.openxmlformats.org/presentationml/2006/main" xmlns:r="http://schemas.openxmlformats.org/officeDocument/2006/relationships">
+  <p:cSld>
+    <p:spTree>
+      <p:nvGrpSpPr>
+        <p:cNvPr id="1" name=""/>
+        <p:cNvGrpSpPr/>
+        <p:nvPr/>
+      </p:nvGrpSpPr>
+      <p:grpSpPr>
+        <a:xfrm>
+          <a:off x="0" y="0"/>
+          <a:ext cx="0" cy="0"/>
+          <a:chOff x="0" y="0"/>
+          <a:chExt cx="0" cy="0"/>
+        </a:xfrm>
+      </p:grpSpPr>
+      <p:pic>
+        <p:nvPicPr>
+          <p:cNvPr id="2" name="root.layers.12" descr="root.layers.12"/>
+          <p:cNvPicPr>
+            <a:picLocks noChangeAspect="1"/>
+          </p:cNvPicPr>
+          <p:nvPr/>
+        </p:nvPicPr>
+        <p:blipFill>
+          <a:blip r:embed="slide13Image"/>
+          <a:stretch>
+            <a:fillRect/>
+          </a:stretch>
+        </p:blipFill>
+        <p:spPr>
+          <a:xfrm>
+            <a:off x="0" y="842920"/>
+            <a:ext cx="9144000" cy="3457660"/>
+          </a:xfrm>
+          <a:prstGeom prst="rect">
+            <a:avLst/>
+          </a:prstGeom>
+        </p:spPr>
+      </p:pic>
+      <p:sp>
+        <p:nvSpPr>
+          <p:cNvPr id="95" name="root.layers.12"/>
           <p:cNvSpPr txBox="1"/>
           <p:nvPr/>
         </p:nvSpPr>
@@ -3222,8 +3584,8 @@
         </p:blipFill>
         <p:spPr>
           <a:xfrm>
-            <a:off x="0" y="75449"/>
-            <a:ext cx="9144000" cy="4992602"/>
+            <a:off x="1072467" y="0"/>
+            <a:ext cx="6999066" cy="5143500"/>
           </a:xfrm>
           <a:prstGeom prst="rect">
             <a:avLst/>
@@ -3311,8 +3673,8 @@
         </p:blipFill>
         <p:spPr>
           <a:xfrm>
-            <a:off x="0" y="1059782"/>
-            <a:ext cx="9144000" cy="3023936"/>
+            <a:off x="348863" y="92849"/>
+            <a:ext cx="8446273" cy="4957801"/>
           </a:xfrm>
           <a:prstGeom prst="rect">
             <a:avLst/>
@@ -3400,8 +3762,8 @@
         </p:blipFill>
         <p:spPr>
           <a:xfrm>
-            <a:off x="0" y="796627"/>
-            <a:ext cx="9144000" cy="3550245"/>
+            <a:off x="982944" y="0"/>
+            <a:ext cx="7178112" cy="5143500"/>
           </a:xfrm>
           <a:prstGeom prst="rect">
             <a:avLst/>
@@ -3489,8 +3851,8 @@
         </p:blipFill>
         <p:spPr>
           <a:xfrm>
-            <a:off x="0" y="769024"/>
-            <a:ext cx="9144000" cy="3605451"/>
+            <a:off x="0" y="75449"/>
+            <a:ext cx="9144000" cy="4992602"/>
           </a:xfrm>
           <a:prstGeom prst="rect">
             <a:avLst/>
@@ -3578,8 +3940,8 @@
         </p:blipFill>
         <p:spPr>
           <a:xfrm>
-            <a:off x="0" y="936414"/>
-            <a:ext cx="9144000" cy="3270671"/>
+            <a:off x="364422" y="0"/>
+            <a:ext cx="8415156" cy="5143500"/>
           </a:xfrm>
           <a:prstGeom prst="rect">
             <a:avLst/>
@@ -3667,8 +4029,8 @@
         </p:blipFill>
         <p:spPr>
           <a:xfrm>
-            <a:off x="0" y="842920"/>
-            <a:ext cx="9144000" cy="3457660"/>
+            <a:off x="792919" y="0"/>
+            <a:ext cx="7558162" cy="5143500"/>
           </a:xfrm>
           <a:prstGeom prst="rect">
             <a:avLst/>
@@ -3678,6 +4040,184 @@
       <p:sp>
         <p:nvSpPr>
           <p:cNvPr id="95" name="root.layers.6"/>
+          <p:cNvSpPr txBox="1"/>
+          <p:nvPr/>
+        </p:nvSpPr>
+        <p:spPr>
+          <a:xfrm>
+            <a:off x="4001" y="6239"/>
+            <a:ext cx="9135998" cy="0"/>
+          </a:xfrm>
+          <a:prstGeom prst="rect">
+            <a:avLst/>
+          </a:prstGeom>
+          <a:ln w="12700">
+            <a:miter lim="400000"/>
+          </a:ln>
+          <a:extLst>
+            <a:ext uri="{C572A759-6A51-4108-AA02-DFA0A04FC94B}">
+              <ma14:wrappingTextBoxFlag xmlns:ma14="http://schemas.microsoft.com/office/mac/drawingml/2011/main" xmlns="" val="1"/>
+            </a:ext>
+          </a:extLst>
+        </p:spPr>
+        <p:txBody>
+          <a:bodyPr lIns="45719" rIns="45719">
+            <a:spAutoFit/>
+          </a:bodyPr>
+          <a:lstStyle>
+            <a:lvl1pPr>
+              <a:defRPr sz="2400"/>
+            </a:lvl1pPr>
+          </a:lstStyle>
+          <a:p>
+            <a:r>
+              <a:rPr b="1"/>
+              <a:t/>
+            </a:r>
+          </a:p>
+        </p:txBody>
+      </p:sp>
+    </p:spTree>
+  </p:cSld>
+  <p:clrMapOvr>
+    <a:masterClrMapping/>
+  </p:clrMapOvr>
+</p:sld>
+</file>
+
+<file path=ppt/slides/slide8.xml><?xml version="1.0" encoding="utf-8"?>
+<p:sld xmlns:a="http://schemas.openxmlformats.org/drawingml/2006/main" xmlns:p="http://schemas.openxmlformats.org/presentationml/2006/main" xmlns:r="http://schemas.openxmlformats.org/officeDocument/2006/relationships">
+  <p:cSld>
+    <p:spTree>
+      <p:nvGrpSpPr>
+        <p:cNvPr id="1" name=""/>
+        <p:cNvGrpSpPr/>
+        <p:nvPr/>
+      </p:nvGrpSpPr>
+      <p:grpSpPr>
+        <a:xfrm>
+          <a:off x="0" y="0"/>
+          <a:ext cx="0" cy="0"/>
+          <a:chOff x="0" y="0"/>
+          <a:chExt cx="0" cy="0"/>
+        </a:xfrm>
+      </p:grpSpPr>
+      <p:pic>
+        <p:nvPicPr>
+          <p:cNvPr id="2" name="root.layers.7" descr="root.layers.7"/>
+          <p:cNvPicPr>
+            <a:picLocks noChangeAspect="1"/>
+          </p:cNvPicPr>
+          <p:nvPr/>
+        </p:nvPicPr>
+        <p:blipFill>
+          <a:blip r:embed="slide8Image"/>
+          <a:stretch>
+            <a:fillRect/>
+          </a:stretch>
+        </p:blipFill>
+        <p:spPr>
+          <a:xfrm>
+            <a:off x="1756097" y="0"/>
+            <a:ext cx="5631806" cy="5143500"/>
+          </a:xfrm>
+          <a:prstGeom prst="rect">
+            <a:avLst/>
+          </a:prstGeom>
+        </p:spPr>
+      </p:pic>
+      <p:sp>
+        <p:nvSpPr>
+          <p:cNvPr id="95" name="root.layers.7"/>
+          <p:cNvSpPr txBox="1"/>
+          <p:nvPr/>
+        </p:nvSpPr>
+        <p:spPr>
+          <a:xfrm>
+            <a:off x="4001" y="6239"/>
+            <a:ext cx="9135998" cy="0"/>
+          </a:xfrm>
+          <a:prstGeom prst="rect">
+            <a:avLst/>
+          </a:prstGeom>
+          <a:ln w="12700">
+            <a:miter lim="400000"/>
+          </a:ln>
+          <a:extLst>
+            <a:ext uri="{C572A759-6A51-4108-AA02-DFA0A04FC94B}">
+              <ma14:wrappingTextBoxFlag xmlns:ma14="http://schemas.microsoft.com/office/mac/drawingml/2011/main" xmlns="" val="1"/>
+            </a:ext>
+          </a:extLst>
+        </p:spPr>
+        <p:txBody>
+          <a:bodyPr lIns="45719" rIns="45719">
+            <a:spAutoFit/>
+          </a:bodyPr>
+          <a:lstStyle>
+            <a:lvl1pPr>
+              <a:defRPr sz="2400"/>
+            </a:lvl1pPr>
+          </a:lstStyle>
+          <a:p>
+            <a:r>
+              <a:rPr b="1"/>
+              <a:t/>
+            </a:r>
+          </a:p>
+        </p:txBody>
+      </p:sp>
+    </p:spTree>
+  </p:cSld>
+  <p:clrMapOvr>
+    <a:masterClrMapping/>
+  </p:clrMapOvr>
+</p:sld>
+</file>
+
+<file path=ppt/slides/slide9.xml><?xml version="1.0" encoding="utf-8"?>
+<p:sld xmlns:a="http://schemas.openxmlformats.org/drawingml/2006/main" xmlns:p="http://schemas.openxmlformats.org/presentationml/2006/main" xmlns:r="http://schemas.openxmlformats.org/officeDocument/2006/relationships">
+  <p:cSld>
+    <p:spTree>
+      <p:nvGrpSpPr>
+        <p:cNvPr id="1" name=""/>
+        <p:cNvGrpSpPr/>
+        <p:nvPr/>
+      </p:nvGrpSpPr>
+      <p:grpSpPr>
+        <a:xfrm>
+          <a:off x="0" y="0"/>
+          <a:ext cx="0" cy="0"/>
+          <a:chOff x="0" y="0"/>
+          <a:chExt cx="0" cy="0"/>
+        </a:xfrm>
+      </p:grpSpPr>
+      <p:pic>
+        <p:nvPicPr>
+          <p:cNvPr id="2" name="root.layers.8" descr="root.layers.8"/>
+          <p:cNvPicPr>
+            <a:picLocks noChangeAspect="1"/>
+          </p:cNvPicPr>
+          <p:nvPr/>
+        </p:nvPicPr>
+        <p:blipFill>
+          <a:blip r:embed="slide9Image"/>
+          <a:stretch>
+            <a:fillRect/>
+          </a:stretch>
+        </p:blipFill>
+        <p:spPr>
+          <a:xfrm>
+            <a:off x="0" y="796627"/>
+            <a:ext cx="9144000" cy="3550245"/>
+          </a:xfrm>
+          <a:prstGeom prst="rect">
+            <a:avLst/>
+          </a:prstGeom>
+        </p:spPr>
+      </p:pic>
+      <p:sp>
+        <p:nvSpPr>
+          <p:cNvPr id="95" name="root.layers.8"/>
           <p:cNvSpPr txBox="1"/>
           <p:nvPr/>
         </p:nvSpPr>

</xml_diff>